<commit_message>
Frame deck for pre-filing IPR committee approval
Co-authored-by: arena-agent <297053741+arena-agent@users.noreply.github.com>
</commit_message>
<xml_diff>
--- a/deliverables/IITBBS_Impact_Dissipating_Crash_Barrier_External_Redacted.pptx
+++ b/deliverables/IITBBS_Impact_Dissipating_Crash_Barrier_External_Redacted.pptx
@@ -3087,7 +3087,7 @@
                 </a:solidFill>
                 <a:latin typeface="Aptos"/>
               </a:rPr>
-              <a:t>• The internal disclosure states that no patent had been filed as of 16 July 2026 and that a related manuscript was submitted on 18 July 2026. Treat this deck accordingly: EXTERNAL REDACTED DRAFT • IP STATUS TO CONFIRM • DISTRIBUTE ONLY WITH IITBBS IP APPROVAL.</a:t>
+              <a:t>• The inventors confirm that the patent has not yet been filed. This is the pre-filing presentation to the IIT Bhubaneswar IPR section seeking approval to proceed with professional drafting and filing. A related manuscript was submitted on 18 July 2026, so confidentiality and disclosure timing are critical. Treat this deck accordingly: EXTERNAL REDACTED DRAFT • NOT FOR DISTRIBUTION BEFORE FILING • IITBBS IPR APPROVAL REQUIRED.</a:t>
             </a:r>
           </a:p>
           <a:p>
@@ -4154,7 +4154,7 @@
                 </a:solidFill>
                 <a:latin typeface="Aptos"/>
               </a:rPr>
-              <a:t>• The recommendation is to proceed with a focused patent filing, because the team has reduced the concept to practice and demonstrated a distinctive combination of lower reported density, retained structural strength, major repeated-impact endurance and a positive one-third-scale barrier result.</a:t>
+              <a:t>• The recommendation to the IIT Bhubaneswar IPR section is to approve proceeding with a focused patent filing. The team has reduced the concept to practice and demonstrated a distinctive combination of lower reported density, retained structural strength, major repeated-impact endurance and a positive one-third-scale barrier result.</a:t>
             </a:r>
           </a:p>
           <a:p>
@@ -4176,7 +4176,7 @@
                 </a:solidFill>
                 <a:latin typeface="Aptos"/>
               </a:rPr>
-              <a:t>• Four approvals are requested: authorize professional drafting and searching; coordinate or pause public disclosure until filing; fund a staged validation programme; and engage a crash-test/precast partner.</a:t>
+              <a:t>• Four IPR decisions are requested: approve professional prior-art searching, drafting and filing; maintain confidentiality and coordinate manuscript release; endorse a staged validation programme; and enable controlled engagement with crash-test and precast partners.</a:t>
             </a:r>
           </a:p>
           <a:p>
@@ -4198,7 +4198,7 @@
                 </a:solidFill>
                 <a:latin typeface="Aptos"/>
               </a:rPr>
-              <a:t>• Final line: protect the invention now, validate the occupant benefit next, and commercialize only after the full-scale safety gate is passed.</a:t>
+              <a:t>• Final line: approve protection now, validate the occupant benefit next, and commercialize only after the full-scale safety gate is passed.</a:t>
             </a:r>
           </a:p>
         </p:txBody>
@@ -8972,7 +8972,7 @@
                 </a:solidFill>
                 <a:latin typeface="Aptos"/>
               </a:rPr>
-              <a:t>Supplied disclosure: not filed as of 16 Jul 2026  •  Reduction to practice: Apr 2026</a:t>
+              <a:t>Current status: not yet filed  •  Purpose: IPR approval to proceed with patent filing</a:t>
             </a:r>
           </a:p>
         </p:txBody>
@@ -9085,7 +9085,7 @@
                 </a:solidFill>
                 <a:latin typeface="Aptos"/>
               </a:rPr>
-              <a:t>EXTERNAL REDACTED DRAFT • IP STATUS TO CONFIRM • DISTRIBUTE ONLY WITH IITBBS IP APPROVAL</a:t>
+              <a:t>EXTERNAL REDACTED DRAFT • NOT FOR DISTRIBUTION BEFORE FILING • IITBBS IPR APPROVAL REQUIRED</a:t>
             </a:r>
           </a:p>
         </p:txBody>
@@ -9406,7 +9406,7 @@
                 </a:solidFill>
                 <a:latin typeface="Aptos"/>
               </a:rPr>
-              <a:t>EXTERNAL REDACTED DRAFT • IP STATUS TO CONFIRM • DISTRIBUTE ONLY WITH IITBBS IP APPROVAL</a:t>
+              <a:t>EXTERNAL REDACTED DRAFT • NOT FOR DISTRIBUTION BEFORE FILING • IITBBS IPR APPROVAL REQUIRED</a:t>
             </a:r>
           </a:p>
         </p:txBody>
@@ -10224,7 +10224,7 @@
                 </a:solidFill>
                 <a:latin typeface="Aptos"/>
               </a:rPr>
-              <a:t>EXTERNAL REDACTED DRAFT • IP STATUS TO CONFIRM • DISTRIBUTE ONLY WITH IITBBS IP APPROVAL</a:t>
+              <a:t>EXTERNAL REDACTED DRAFT • NOT FOR DISTRIBUTION BEFORE FILING • IITBBS IPR APPROVAL REQUIRED</a:t>
             </a:r>
           </a:p>
         </p:txBody>
@@ -11651,7 +11651,7 @@
                 </a:solidFill>
                 <a:latin typeface="Aptos"/>
               </a:rPr>
-              <a:t>EXTERNAL REDACTED DRAFT • IP STATUS TO CONFIRM • DISTRIBUTE ONLY WITH IITBBS IP APPROVAL</a:t>
+              <a:t>EXTERNAL REDACTED DRAFT • NOT FOR DISTRIBUTION BEFORE FILING • IITBBS IPR APPROVAL REQUIRED</a:t>
             </a:r>
           </a:p>
         </p:txBody>
@@ -12469,7 +12469,7 @@
                 </a:solidFill>
                 <a:latin typeface="Aptos"/>
               </a:rPr>
-              <a:t>EXTERNAL REDACTED DRAFT • IP STATUS TO CONFIRM • DISTRIBUTE ONLY WITH IITBBS IP APPROVAL</a:t>
+              <a:t>EXTERNAL REDACTED DRAFT • NOT FOR DISTRIBUTION BEFORE FILING • IITBBS IPR APPROVAL REQUIRED</a:t>
             </a:r>
           </a:p>
         </p:txBody>
@@ -13447,7 +13447,7 @@
                 </a:solidFill>
                 <a:latin typeface="Aptos"/>
               </a:rPr>
-              <a:t>EXTERNAL REDACTED DRAFT • IP STATUS TO CONFIRM • DISTRIBUTE ONLY WITH IITBBS IP APPROVAL</a:t>
+              <a:t>EXTERNAL REDACTED DRAFT • NOT FOR DISTRIBUTION BEFORE FILING • IITBBS IPR APPROVAL REQUIRED</a:t>
             </a:r>
           </a:p>
         </p:txBody>
@@ -14398,7 +14398,7 @@
                 </a:solidFill>
                 <a:latin typeface="Aptos"/>
               </a:rPr>
-              <a:t>EXTERNAL REDACTED DRAFT • IP STATUS TO CONFIRM • DISTRIBUTE ONLY WITH IITBBS IP APPROVAL</a:t>
+              <a:t>EXTERNAL REDACTED DRAFT • NOT FOR DISTRIBUTION BEFORE FILING • IITBBS IPR APPROVAL REQUIRED</a:t>
             </a:r>
           </a:p>
         </p:txBody>
@@ -16377,7 +16377,7 @@
                 </a:solidFill>
                 <a:latin typeface="Aptos"/>
               </a:rPr>
-              <a:t>EXTERNAL REDACTED DRAFT • IP STATUS TO CONFIRM • DISTRIBUTE ONLY WITH IITBBS IP APPROVAL</a:t>
+              <a:t>EXTERNAL REDACTED DRAFT • NOT FOR DISTRIBUTION BEFORE FILING • IITBBS IPR APPROVAL REQUIRED</a:t>
             </a:r>
           </a:p>
         </p:txBody>
@@ -18526,7 +18526,7 @@
                 </a:solidFill>
                 <a:latin typeface="Aptos Display"/>
               </a:rPr>
-              <a:t>Decision proposition: protect the platform, fund the validation</a:t>
+              <a:t>Decision request: approve patent filing and staged validation</a:t>
             </a:r>
           </a:p>
         </p:txBody>
@@ -18704,7 +18704,7 @@
                 </a:solidFill>
                 <a:latin typeface="Aptos"/>
               </a:rPr>
-              <a:t>EXTERNAL REDACTED DRAFT • IP STATUS TO CONFIRM • DISTRIBUTE ONLY WITH IITBBS IP APPROVAL</a:t>
+              <a:t>EXTERNAL REDACTED DRAFT • NOT FOR DISTRIBUTION BEFORE FILING • IITBBS IPR APPROVAL REQUIRED</a:t>
             </a:r>
           </a:p>
         </p:txBody>
@@ -18782,8 +18782,8 @@
                 </a:solidFill>
                 <a:latin typeface="Aptos Display"/>
               </a:rPr>
-              <a:t>The evidence is sufficient to justify a focused patent filing—
-not yet sufficient to claim certified occupant-safety benefit.</a:t>
+              <a:t>The evidence justifies IPR approval to proceed with a focused patent filing—
+not yet a certified occupant-safety claim.</a:t>
             </a:r>
           </a:p>
         </p:txBody>
@@ -19236,7 +19236,7 @@
                 </a:solidFill>
                 <a:latin typeface="Aptos"/>
               </a:rPr>
-              <a:t>APPROVALS REQUESTED</a:t>
+              <a:t>IPR DECISIONS REQUESTED</a:t>
             </a:r>
           </a:p>
         </p:txBody>
@@ -19334,7 +19334,7 @@
         <p:spPr>
           <a:xfrm>
             <a:off x="8833104" y="2093976"/>
-            <a:ext cx="2011680" cy="256032"/>
+            <a:ext cx="2267712" cy="329184"/>
           </a:xfrm>
           <a:prstGeom prst="rect">
             <a:avLst/>
@@ -19353,13 +19353,13 @@
               </a:lnSpc>
             </a:pPr>
             <a:r>
-              <a:rPr sz="980" b="1" i="0">
+              <a:rPr sz="940" b="1" i="0">
                 <a:solidFill>
                   <a:srgbClr val="172733"/>
                 </a:solidFill>
                 <a:latin typeface="Aptos"/>
               </a:rPr>
-              <a:t>Authorize patent drafting</a:t>
+              <a:t>Approve patent filing</a:t>
             </a:r>
           </a:p>
         </p:txBody>
@@ -19372,8 +19372,8 @@
         </p:nvSpPr>
         <p:spPr>
           <a:xfrm>
-            <a:off x="8833104" y="2386584"/>
-            <a:ext cx="2039112" cy="365760"/>
+            <a:off x="8833104" y="2423160"/>
+            <a:ext cx="2176272" cy="347472"/>
           </a:xfrm>
           <a:prstGeom prst="rect">
             <a:avLst/>
@@ -19392,13 +19392,13 @@
               </a:lnSpc>
             </a:pPr>
             <a:r>
-              <a:rPr sz="810" b="0" i="0">
+              <a:rPr sz="790" b="0" i="0">
                 <a:solidFill>
                   <a:srgbClr val="596C78"/>
                 </a:solidFill>
                 <a:latin typeface="Aptos"/>
               </a:rPr>
-              <a:t>Composition + process + barrier + use claims</a:t>
+              <a:t>Authorize search, drafting and filing</a:t>
             </a:r>
           </a:p>
         </p:txBody>
@@ -19496,7 +19496,7 @@
         <p:spPr>
           <a:xfrm>
             <a:off x="8833104" y="2926080"/>
-            <a:ext cx="2011680" cy="256032"/>
+            <a:ext cx="2267712" cy="329184"/>
           </a:xfrm>
           <a:prstGeom prst="rect">
             <a:avLst/>
@@ -19515,13 +19515,13 @@
               </a:lnSpc>
             </a:pPr>
             <a:r>
-              <a:rPr sz="980" b="1" i="0">
+              <a:rPr sz="940" b="1" i="0">
                 <a:solidFill>
                   <a:srgbClr val="172733"/>
                 </a:solidFill>
                 <a:latin typeface="Aptos"/>
               </a:rPr>
-              <a:t>Freeze public disclosure</a:t>
+              <a:t>Maintain confidentiality</a:t>
             </a:r>
           </a:p>
         </p:txBody>
@@ -19534,8 +19534,8 @@
         </p:nvSpPr>
         <p:spPr>
           <a:xfrm>
-            <a:off x="8833104" y="3218688"/>
-            <a:ext cx="2039112" cy="365760"/>
+            <a:off x="8833104" y="3255264"/>
+            <a:ext cx="2176272" cy="347472"/>
           </a:xfrm>
           <a:prstGeom prst="rect">
             <a:avLst/>
@@ -19554,13 +19554,13 @@
               </a:lnSpc>
             </a:pPr>
             <a:r>
-              <a:rPr sz="810" b="0" i="0">
+              <a:rPr sz="790" b="0" i="0">
                 <a:solidFill>
                   <a:srgbClr val="596C78"/>
                 </a:solidFill>
                 <a:latin typeface="Aptos"/>
               </a:rPr>
-              <a:t>Coordinate manuscript timing with filing</a:t>
+              <a:t>Coordinate manuscript release after filing</a:t>
             </a:r>
           </a:p>
         </p:txBody>
@@ -19658,7 +19658,7 @@
         <p:spPr>
           <a:xfrm>
             <a:off x="8833104" y="3758184"/>
-            <a:ext cx="2011680" cy="256032"/>
+            <a:ext cx="2267712" cy="329184"/>
           </a:xfrm>
           <a:prstGeom prst="rect">
             <a:avLst/>
@@ -19677,13 +19677,13 @@
               </a:lnSpc>
             </a:pPr>
             <a:r>
-              <a:rPr sz="980" b="1" i="0">
+              <a:rPr sz="940" b="1" i="0">
                 <a:solidFill>
                   <a:srgbClr val="172733"/>
                 </a:solidFill>
                 <a:latin typeface="Aptos"/>
               </a:rPr>
-              <a:t>Fund validation gate</a:t>
+              <a:t>Endorse validation plan</a:t>
             </a:r>
           </a:p>
         </p:txBody>
@@ -19696,8 +19696,8 @@
         </p:nvSpPr>
         <p:spPr>
           <a:xfrm>
-            <a:off x="8833104" y="4050791"/>
-            <a:ext cx="2039112" cy="365760"/>
+            <a:off x="8833104" y="4087368"/>
+            <a:ext cx="2176272" cy="347472"/>
           </a:xfrm>
           <a:prstGeom prst="rect">
             <a:avLst/>
@@ -19716,7 +19716,7 @@
               </a:lnSpc>
             </a:pPr>
             <a:r>
-              <a:rPr sz="810" b="0" i="0">
+              <a:rPr sz="790" b="0" i="0">
                 <a:solidFill>
                   <a:srgbClr val="596C78"/>
                 </a:solidFill>
@@ -19820,7 +19820,7 @@
         <p:spPr>
           <a:xfrm>
             <a:off x="8833104" y="4590288"/>
-            <a:ext cx="2011680" cy="256032"/>
+            <a:ext cx="2267712" cy="329184"/>
           </a:xfrm>
           <a:prstGeom prst="rect">
             <a:avLst/>
@@ -19839,13 +19839,13 @@
               </a:lnSpc>
             </a:pPr>
             <a:r>
-              <a:rPr sz="980" b="1" i="0">
+              <a:rPr sz="940" b="1" i="0">
                 <a:solidFill>
                   <a:srgbClr val="172733"/>
                 </a:solidFill>
                 <a:latin typeface="Aptos"/>
               </a:rPr>
-              <a:t>Open partner pathway</a:t>
+              <a:t>Enable technology transfer</a:t>
             </a:r>
           </a:p>
         </p:txBody>
@@ -19858,8 +19858,8 @@
         </p:nvSpPr>
         <p:spPr>
           <a:xfrm>
-            <a:off x="8833104" y="4882896"/>
-            <a:ext cx="2039112" cy="365760"/>
+            <a:off x="8833104" y="4919472"/>
+            <a:ext cx="2176272" cy="347472"/>
           </a:xfrm>
           <a:prstGeom prst="rect">
             <a:avLst/>
@@ -19878,13 +19878,13 @@
               </a:lnSpc>
             </a:pPr>
             <a:r>
-              <a:rPr sz="810" b="0" i="0">
+              <a:rPr sz="790" b="0" i="0">
                 <a:solidFill>
                   <a:srgbClr val="596C78"/>
                 </a:solidFill>
                 <a:latin typeface="Aptos"/>
               </a:rPr>
-              <a:t>CRRI / NHAI / precast / barrier manufacturer</a:t>
+              <a:t>Controlled CRRI / NHAI / precast engagement</a:t>
             </a:r>
           </a:p>
         </p:txBody>
@@ -20007,7 +20007,7 @@
                 </a:solidFill>
                 <a:latin typeface="Aptos"/>
               </a:rPr>
-              <a:t>Protect the integrated material–mechanism–barrier platform now; make full-scale occupant-risk validation the commercial release gate.</a:t>
+              <a:t>Approve filing now; retain full-scale occupant-risk validation as the commercial release gate.</a:t>
             </a:r>
           </a:p>
         </p:txBody>
@@ -20046,7 +20046,7 @@
                 </a:solidFill>
                 <a:latin typeface="Aptos"/>
               </a:rPr>
-              <a:t>Source: Recommendation based on inventor-supplied evidence and disclosed patent status as of 16 Jul 2026. No legal, safety-certification or investment assurance is implied.</a:t>
+              <a:t>Source: Recommendation based on inventor-supplied evidence and inventor-confirmed pre-filing status as of 13 Aug 2026. No legal, safety-certification or investment assurance is implied.</a:t>
             </a:r>
           </a:p>
         </p:txBody>
@@ -20328,7 +20328,7 @@
                 </a:solidFill>
                 <a:latin typeface="Aptos"/>
               </a:rPr>
-              <a:t>EXTERNAL REDACTED DRAFT • IP STATUS TO CONFIRM • DISTRIBUTE ONLY WITH IITBBS IP APPROVAL</a:t>
+              <a:t>EXTERNAL REDACTED DRAFT • NOT FOR DISTRIBUTION BEFORE FILING • IITBBS IPR APPROVAL REQUIRED</a:t>
             </a:r>
           </a:p>
         </p:txBody>
@@ -21246,7 +21246,7 @@
                 </a:solidFill>
                 <a:latin typeface="Aptos"/>
               </a:rPr>
-              <a:t>EXTERNAL REDACTED DRAFT • IP STATUS TO CONFIRM • DISTRIBUTE ONLY WITH IITBBS IP APPROVAL</a:t>
+              <a:t>EXTERNAL REDACTED DRAFT • NOT FOR DISTRIBUTION BEFORE FILING • IITBBS IPR APPROVAL REQUIRED</a:t>
             </a:r>
           </a:p>
         </p:txBody>
@@ -22203,7 +22203,7 @@
                 </a:solidFill>
                 <a:latin typeface="Aptos"/>
               </a:rPr>
-              <a:t>EXTERNAL REDACTED DRAFT • IP STATUS TO CONFIRM • DISTRIBUTE ONLY WITH IITBBS IP APPROVAL</a:t>
+              <a:t>EXTERNAL REDACTED DRAFT • NOT FOR DISTRIBUTION BEFORE FILING • IITBBS IPR APPROVAL REQUIRED</a:t>
             </a:r>
           </a:p>
         </p:txBody>
@@ -23871,7 +23871,7 @@
                 </a:solidFill>
                 <a:latin typeface="Aptos"/>
               </a:rPr>
-              <a:t>EXTERNAL REDACTED DRAFT • IP STATUS TO CONFIRM • DISTRIBUTE ONLY WITH IITBBS IP APPROVAL</a:t>
+              <a:t>EXTERNAL REDACTED DRAFT • NOT FOR DISTRIBUTION BEFORE FILING • IITBBS IPR APPROVAL REQUIRED</a:t>
             </a:r>
           </a:p>
         </p:txBody>
@@ -25099,7 +25099,7 @@
                 </a:solidFill>
                 <a:latin typeface="Aptos"/>
               </a:rPr>
-              <a:t>EXTERNAL REDACTED DRAFT • IP STATUS TO CONFIRM • DISTRIBUTE ONLY WITH IITBBS IP APPROVAL</a:t>
+              <a:t>EXTERNAL REDACTED DRAFT • NOT FOR DISTRIBUTION BEFORE FILING • IITBBS IPR APPROVAL REQUIRED</a:t>
             </a:r>
           </a:p>
         </p:txBody>
@@ -26592,7 +26592,7 @@
                 </a:solidFill>
                 <a:latin typeface="Aptos"/>
               </a:rPr>
-              <a:t>EXTERNAL REDACTED DRAFT • IP STATUS TO CONFIRM • DISTRIBUTE ONLY WITH IITBBS IP APPROVAL</a:t>
+              <a:t>EXTERNAL REDACTED DRAFT • NOT FOR DISTRIBUTION BEFORE FILING • IITBBS IPR APPROVAL REQUIRED</a:t>
             </a:r>
           </a:p>
         </p:txBody>
@@ -28479,7 +28479,7 @@
                 </a:solidFill>
                 <a:latin typeface="Aptos"/>
               </a:rPr>
-              <a:t>EXTERNAL REDACTED DRAFT • IP STATUS TO CONFIRM • DISTRIBUTE ONLY WITH IITBBS IP APPROVAL</a:t>
+              <a:t>EXTERNAL REDACTED DRAFT • NOT FOR DISTRIBUTION BEFORE FILING • IITBBS IPR APPROVAL REQUIRED</a:t>
             </a:r>
           </a:p>
         </p:txBody>
@@ -30357,7 +30357,7 @@
                 </a:solidFill>
                 <a:latin typeface="Aptos"/>
               </a:rPr>
-              <a:t>EXTERNAL REDACTED DRAFT • IP STATUS TO CONFIRM • DISTRIBUTE ONLY WITH IITBBS IP APPROVAL</a:t>
+              <a:t>EXTERNAL REDACTED DRAFT • NOT FOR DISTRIBUTION BEFORE FILING • IITBBS IPR APPROVAL REQUIRED</a:t>
             </a:r>
           </a:p>
         </p:txBody>
@@ -31395,7 +31395,7 @@
                 </a:solidFill>
                 <a:latin typeface="Aptos"/>
               </a:rPr>
-              <a:t>EXTERNAL REDACTED DRAFT • IP STATUS TO CONFIRM • DISTRIBUTE ONLY WITH IITBBS IP APPROVAL</a:t>
+              <a:t>EXTERNAL REDACTED DRAFT • NOT FOR DISTRIBUTION BEFORE FILING • IITBBS IPR APPROVAL REQUIRED</a:t>
             </a:r>
           </a:p>
         </p:txBody>
@@ -32268,7 +32268,7 @@
                 </a:solidFill>
                 <a:latin typeface="Aptos"/>
               </a:rPr>
-              <a:t>EXTERNAL REDACTED DRAFT • IP STATUS TO CONFIRM • DISTRIBUTE ONLY WITH IITBBS IP APPROVAL</a:t>
+              <a:t>EXTERNAL REDACTED DRAFT • NOT FOR DISTRIBUTION BEFORE FILING • IITBBS IPR APPROVAL REQUIRED</a:t>
             </a:r>
           </a:p>
         </p:txBody>

</xml_diff>